<commit_message>
QR passenger cards in Corruseal's look, with a real photo
The cards now lead with the Corruseal Group logo, in their orange and charcoal,
and the front shows a real portrait (a free Adobe Stock photo licensed for the
sample). The deck carries the new cards, with a soft shadow so they stand off
the slide.

Co-Authored-By: Claude Opus 5.5 <noreply@anthropic.com>
Claude-Session: https://claude.ai/code/session_01H8nUNRrGeaWWu1NrRdz9Wv
</commit_message>
<xml_diff>
--- a/marketing/qr-registry/QR automated registry.pptx
+++ b/marketing/qr-registry/QR automated registry.pptx
@@ -116,12 +116,12 @@
   <p:extLst>
     <p:ext uri="{521415D9-36F7-43E2-AB2F-B90AF26B5E84}">
       <p14:sectionLst xmlns:p14="http://schemas.microsoft.com/office/powerpoint/2010/main">
-        <p14:section name="Introduction" id="{6bdacc32-f452-878f-b003-c3adebdfc434}">
+        <p14:section name="Introduction" id="{82b9e746-6dd3-b380-401a-638775c06ce4}">
           <p14:sldIdLst>
             <p14:sldId id="256"/>
           </p14:sldIdLst>
         </p14:section>
-        <p14:section name="How it works" id="{ba65dc35-a019-e114-3cca-674e2f38cc8d}">
+        <p14:section name="How it works" id="{2d984a3e-2cd5-473c-3d2a-d7c4500421d9}">
           <p14:sldIdLst>
             <p14:sldId id="257"/>
             <p14:sldId id="258"/>
@@ -129,19 +129,19 @@
             <p14:sldId id="260"/>
           </p14:sldIdLst>
         </p14:section>
-        <p14:section name="The card" id="{ec73dbd4-df6a-ec9e-ab64-adbb19d1b4d2}">
+        <p14:section name="The card" id="{f6b18cee-d174-fb80-ed2f-95bfe066c358}">
           <p14:sldIdLst>
             <p14:sldId id="261"/>
             <p14:sldId id="262"/>
             <p14:sldId id="263"/>
           </p14:sldIdLst>
         </p14:section>
-        <p14:section name="Recommendations" id="{4aa7198a-dfd4-5958-7fa1-40c06651b444}">
+        <p14:section name="Recommendations" id="{ddfcea21-b5ad-b4dc-3b94-288b425a21fe}">
           <p14:sldIdLst>
             <p14:sldId id="264"/>
           </p14:sldIdLst>
         </p14:section>
-        <p14:section name="Next steps" id="{08607a93-7bce-968b-1ca8-d444954399d6}">
+        <p14:section name="Next steps" id="{78f36080-b092-1106-c538-74b68613e563}">
           <p14:sldIdLst>
             <p14:sldId id="265"/>
           </p14:sldIdLst>
@@ -5430,6 +5430,13 @@
           <a:prstGeom prst="rect">
             <a:avLst/>
           </a:prstGeom>
+          <a:effectLst>
+            <a:outerShdw sx="100000" sy="100000" kx="0" ky="0" algn="bl" rotWithShape="0" blurRad="127000" dist="38100" dir="5400000">
+              <a:srgbClr val="000000">
+                <a:alpha val="28000"/>
+              </a:srgbClr>
+            </a:outerShdw>
+          </a:effectLst>
         </p:spPr>
       </p:pic>
       <p:pic>
@@ -5454,6 +5461,13 @@
           <a:prstGeom prst="rect">
             <a:avLst/>
           </a:prstGeom>
+          <a:effectLst>
+            <a:outerShdw sx="100000" sy="100000" kx="0" ky="0" algn="bl" rotWithShape="0" blurRad="127000" dist="38100" dir="5400000">
+              <a:srgbClr val="000000">
+                <a:alpha val="28000"/>
+              </a:srgbClr>
+            </a:outerShdw>
+          </a:effectLst>
         </p:spPr>
       </p:pic>
       <p:sp>
@@ -5591,7 +5605,7 @@
                   <a:schemeClr val="tx1"/>
                 </a:solidFill>
               </a:rPr>
-              <a:t>85.6 × 54 mm, the size of a bank card, so it fits a wallet, a lanyard or a card holder. Corruseal's own logo and colours go on the front.</a:t>
+              <a:t>85.6 × 54 mm, the size of a bank card, so it fits a wallet, a lanyard or a card holder. Printed in Corruseal's colours with their logo; the photo shown is a sample.</a:t>
             </a:r>
             <a:endParaRPr lang="en-US" sz="1500" dirty="0"/>
           </a:p>
@@ -5727,6 +5741,13 @@
           <a:prstGeom prst="rect">
             <a:avLst/>
           </a:prstGeom>
+          <a:effectLst>
+            <a:outerShdw sx="100000" sy="100000" kx="0" ky="0" algn="bl" rotWithShape="0" blurRad="127000" dist="38100" dir="5400000">
+              <a:srgbClr val="000000">
+                <a:alpha val="28000"/>
+              </a:srgbClr>
+            </a:outerShdw>
+          </a:effectLst>
         </p:spPr>
       </p:pic>
       <p:sp>

</xml_diff>